<commit_message>
Updates to Platform Map
</commit_message>
<xml_diff>
--- a/sib/portal/AR-Platform-Map.pptx
+++ b/sib/portal/AR-Platform-Map.pptx
@@ -4816,7 +4816,7 @@
                 </a:solidFill>
                 <a:latin typeface="Calibri"/>
               </a:rPr>
-              <a:t>PILOT-READY</a:t>
+              <a:t>POC-READY</a:t>
             </a:r>
           </a:p>
         </p:txBody>
@@ -5717,7 +5717,7 @@
                 </a:solidFill>
                 <a:latin typeface="Calibri"/>
               </a:rPr>
-              <a:t>PILOT-READY</a:t>
+              <a:t>POC-READY</a:t>
             </a:r>
           </a:p>
         </p:txBody>
@@ -6618,7 +6618,7 @@
                 </a:solidFill>
                 <a:latin typeface="Calibri"/>
               </a:rPr>
-              <a:t>PILOT-READY</a:t>
+              <a:t>POC-READY</a:t>
             </a:r>
           </a:p>
         </p:txBody>
@@ -8872,7 +8872,7 @@
                 </a:solidFill>
                 <a:latin typeface="Calibri"/>
               </a:rPr>
-              <a:t>Running continuously; hardened for pilots. Spatial data formats patent-pending.</a:t>
+              <a:t>Running continuously; hardened for POCs. Spatial data formats patent-pending.</a:t>
             </a:r>
           </a:p>
         </p:txBody>

</xml_diff>

<commit_message>
Platform Map Draft v0.2
</commit_message>
<xml_diff>
--- a/sib/portal/AR-Platform-Map.pptx
+++ b/sib/portal/AR-Platform-Map.pptx
@@ -3168,7 +3168,7 @@
                 </a:solidFill>
                 <a:latin typeface="Calibri"/>
               </a:rPr>
-              <a:t>APPLIED MATERIALS · AR OPERATIONS PLATFORM</a:t>
+              <a:t>APPLIED MATERIALS · CONNECTED WORKER AR OMS INITIATIVE</a:t>
             </a:r>
           </a:p>
         </p:txBody>
@@ -3203,7 +3203,7 @@
                 </a:solidFill>
                 <a:latin typeface="Calibri"/>
               </a:rPr>
-              <a:t>Work Instructions that assist technicians as they do it —</a:t>
+              <a:t>Every technician’s next move,</a:t>
             </a:r>
           </a:p>
           <a:p>
@@ -3215,7 +3215,7 @@
                 </a:solidFill>
                 <a:latin typeface="Calibri"/>
               </a:rPr>
-              <a:t>and help to validate immediately.</a:t>
+              <a:t>right the first time.</a:t>
             </a:r>
           </a:p>
         </p:txBody>
@@ -3229,28 +3229,28 @@
         <p:spPr>
           <a:xfrm>
             <a:off x="609584" y="3962399"/>
-            <a:ext cx="9143771" cy="685800"/>
-          </a:xfrm>
-          <a:prstGeom prst="rect">
-            <a:avLst/>
-          </a:prstGeom>
-          <a:noFill/>
-        </p:spPr>
-        <p:txBody>
-          <a:bodyPr wrap="square" anchor="t" lIns="36576" rIns="36576" tIns="18288" bIns="18288">
-            <a:spAutoFit/>
-          </a:bodyPr>
-          <a:lstStyle/>
-          <a:p>
-            <a:pPr algn="l"/>
-            <a:r>
-              <a:rPr sz="1500" b="0">
+            <a:ext cx="9905752" cy="685800"/>
+          </a:xfrm>
+          <a:prstGeom prst="rect">
+            <a:avLst/>
+          </a:prstGeom>
+          <a:noFill/>
+        </p:spPr>
+        <p:txBody>
+          <a:bodyPr wrap="square" anchor="t" lIns="36576" rIns="36576" tIns="18288" bIns="18288">
+            <a:spAutoFit/>
+          </a:bodyPr>
+          <a:lstStyle/>
+          <a:p>
+            <a:pPr algn="l"/>
+            <a:r>
+              <a:rPr sz="1400" b="0">
                 <a:solidFill>
                   <a:srgbClr val="CBD5E1"/>
                 </a:solidFill>
                 <a:latin typeface="Calibri"/>
               </a:rPr>
-              <a:t>Four products on one spatial backbone — built in-house, runs on-prem or in the cloud, and proves every step with evidence.</a:t>
+              <a:t>Adaptive Guided Work Instructions that live on the tool, adapt to the technician, and validate the work as it happens — so we win on Productivity, Velocity and Customer Trust, and our people are ready for semi- and fully-autonomous cleanrooms.</a:t>
             </a:r>
           </a:p>
         </p:txBody>
@@ -3331,7 +3331,7 @@
                 </a:solidFill>
                 <a:latin typeface="Calibri"/>
               </a:rPr>
-              <a:t>Guided</a:t>
+              <a:t>Productivity</a:t>
             </a:r>
           </a:p>
         </p:txBody>
@@ -3366,7 +3366,7 @@
                 </a:solidFill>
                 <a:latin typeface="Calibri"/>
               </a:rPr>
-              <a:t>Steps appear on the equipment itself, in the technician’s field of view.</a:t>
+              <a:t>Hours per procedure and time-to-competency fall — instruction on the tool, check on the spot, no re-work.</a:t>
             </a:r>
           </a:p>
         </p:txBody>
@@ -3447,7 +3447,7 @@
                 </a:solidFill>
                 <a:latin typeface="Calibri"/>
               </a:rPr>
-              <a:t>Validated</a:t>
+              <a:t>Velocity</a:t>
             </a:r>
           </a:p>
         </p:txBody>
@@ -3482,7 +3482,7 @@
                 </a:solidFill>
                 <a:latin typeface="Calibri"/>
               </a:rPr>
-              <a:t>Critical steps are checked spatially before moving on; verdict and score recorded.</a:t>
+              <a:t>A procedure change reaches every chamber of a configuration in minutes, not a training cycle.</a:t>
             </a:r>
           </a:p>
         </p:txBody>
@@ -3563,7 +3563,7 @@
                 </a:solidFill>
                 <a:latin typeface="Calibri"/>
               </a:rPr>
-              <a:t>Evidenced</a:t>
+              <a:t>Customer Trust</a:t>
             </a:r>
           </a:p>
         </p:txBody>
@@ -3598,7 +3598,7 @@
                 </a:solidFill>
                 <a:latin typeface="Calibri"/>
               </a:rPr>
-              <a:t>Every run leaves a usage log — timings, photos, sign-off — exportable to Excel.</a:t>
+              <a:t>Fewer quality issues escape to customer sites — critical steps validated and evidenced before the tool ships.</a:t>
             </a:r>
           </a:p>
         </p:txBody>
@@ -4724,7 +4724,7 @@
                 </a:solidFill>
                 <a:latin typeface="Calibri"/>
               </a:rPr>
-              <a:t>AR Work Instructions</a:t>
+              <a:t>Adaptive Guided Work Instructions</a:t>
             </a:r>
           </a:p>
         </p:txBody>
@@ -9351,7 +9351,7 @@
                 </a:solidFill>
                 <a:latin typeface="Calibri"/>
               </a:rPr>
-              <a:t>AR Work Instructions</a:t>
+              <a:t>Adaptive Guided Work Instructions</a:t>
             </a:r>
           </a:p>
         </p:txBody>
@@ -11865,7 +11865,7 @@
                 </a:solidFill>
                 <a:latin typeface="Calibri"/>
               </a:rPr>
-              <a:t>AR Work</a:t>
+              <a:t>Adaptive Guided</a:t>
             </a:r>
           </a:p>
           <a:p>
@@ -11877,7 +11877,7 @@
                 </a:solidFill>
                 <a:latin typeface="Calibri"/>
               </a:rPr>
-              <a:t>Instructions</a:t>
+              <a:t>Work Instructions</a:t>
             </a:r>
           </a:p>
         </p:txBody>

</xml_diff>

<commit_message>
Platform Map Draft v0.3
</commit_message>
<xml_diff>
--- a/sib/portal/AR-Platform-Map.pptx
+++ b/sib/portal/AR-Platform-Map.pptx
@@ -3229,28 +3229,28 @@
         <p:spPr>
           <a:xfrm>
             <a:off x="609584" y="3962399"/>
-            <a:ext cx="9905752" cy="685800"/>
-          </a:xfrm>
-          <a:prstGeom prst="rect">
-            <a:avLst/>
-          </a:prstGeom>
-          <a:noFill/>
-        </p:spPr>
-        <p:txBody>
-          <a:bodyPr wrap="square" anchor="t" lIns="36576" rIns="36576" tIns="18288" bIns="18288">
-            <a:spAutoFit/>
-          </a:bodyPr>
-          <a:lstStyle/>
-          <a:p>
-            <a:pPr algn="l"/>
-            <a:r>
-              <a:rPr sz="1400" b="0">
+            <a:ext cx="9905752" cy="457200"/>
+          </a:xfrm>
+          <a:prstGeom prst="rect">
+            <a:avLst/>
+          </a:prstGeom>
+          <a:noFill/>
+        </p:spPr>
+        <p:txBody>
+          <a:bodyPr wrap="square" anchor="t" lIns="36576" rIns="36576" tIns="18288" bIns="18288">
+            <a:spAutoFit/>
+          </a:bodyPr>
+          <a:lstStyle/>
+          <a:p>
+            <a:pPr algn="l"/>
+            <a:r>
+              <a:rPr sz="1500" b="0">
                 <a:solidFill>
                   <a:srgbClr val="CBD5E1"/>
                 </a:solidFill>
                 <a:latin typeface="Calibri"/>
               </a:rPr>
-              <a:t>Adaptive Guided Work Instructions that live on the tool, adapt to the technician, and validate the work as it happens — so we win on Productivity, Velocity and Customer Trust, and our people are ready for semi- and fully-autonomous cleanrooms.</a:t>
+              <a:t>Adaptive Guided Work Instructions that live on the tool, adapt to the technician, and validate the work as it happens.</a:t>
             </a:r>
           </a:p>
         </p:txBody>
@@ -3366,7 +3366,8 @@
                 </a:solidFill>
                 <a:latin typeface="Calibri"/>
               </a:rPr>
-              <a:t>Hours per procedure and time-to-competency fall — instruction on the tool, check on the spot, no re-work.</a:t>
+              <a:t>Instruction on the tool, check on the spot, no re-work.
+Measured: TTC · SLH · re-work per run</a:t>
             </a:r>
           </a:p>
         </p:txBody>
@@ -3482,7 +3483,8 @@
                 </a:solidFill>
                 <a:latin typeface="Calibri"/>
               </a:rPr>
-              <a:t>A procedure change reaches every chamber of a configuration in minutes, not a training cycle.</a:t>
+              <a:t>A procedure change reaches every chamber in minutes.
+Measured: CT · reduced downtime</a:t>
             </a:r>
           </a:p>
         </p:txBody>
@@ -3598,7 +3600,8 @@
                 </a:solidFill>
                 <a:latin typeface="Calibri"/>
               </a:rPr>
-              <a:t>Fewer quality issues escape to customer sites — critical steps validated and evidenced before the tool ships.</a:t>
+              <a:t>Fewer quality issues escape to customer sites.
+Measured: Field NCs · Y7, Y8 · Q-reports</a:t>
             </a:r>
           </a:p>
         </p:txBody>
@@ -9144,7 +9147,7 @@
         <p:spPr>
           <a:xfrm>
             <a:off x="457188" y="502920"/>
-            <a:ext cx="7619809" cy="198120"/>
+            <a:ext cx="8381790" cy="198120"/>
           </a:xfrm>
           <a:prstGeom prst="rect">
             <a:avLst/>
@@ -9165,7 +9168,7 @@
                 </a:solidFill>
                 <a:latin typeface="Calibri"/>
               </a:rPr>
-              <a:t>One spatial backbone · four products · authoring, content and governance built in</a:t>
+              <a:t>Connected Worker · AR OMS  ·  one spatial backbone · four products · authoring, content and governance built in</a:t>
             </a:r>
           </a:p>
         </p:txBody>
@@ -9329,29 +9332,41 @@
         </p:nvSpPr>
         <p:spPr>
           <a:xfrm>
-            <a:off x="579105" y="1112520"/>
-            <a:ext cx="2514537" cy="228600"/>
-          </a:xfrm>
-          <a:prstGeom prst="rect">
-            <a:avLst/>
-          </a:prstGeom>
-          <a:noFill/>
-        </p:spPr>
-        <p:txBody>
-          <a:bodyPr wrap="square" anchor="t" lIns="36576" rIns="36576" tIns="18288" bIns="18288">
-            <a:spAutoFit/>
-          </a:bodyPr>
-          <a:lstStyle/>
-          <a:p>
-            <a:pPr algn="l"/>
-            <a:r>
-              <a:rPr sz="1500" b="1">
+            <a:off x="579105" y="1082040"/>
+            <a:ext cx="2514537" cy="396240"/>
+          </a:xfrm>
+          <a:prstGeom prst="rect">
+            <a:avLst/>
+          </a:prstGeom>
+          <a:noFill/>
+        </p:spPr>
+        <p:txBody>
+          <a:bodyPr wrap="square" anchor="t" lIns="36576" rIns="36576" tIns="18288" bIns="18288">
+            <a:spAutoFit/>
+          </a:bodyPr>
+          <a:lstStyle/>
+          <a:p>
+            <a:pPr algn="l"/>
+            <a:r>
+              <a:rPr sz="1350" b="1">
                 <a:solidFill>
                   <a:srgbClr val="FFFFFF"/>
                 </a:solidFill>
                 <a:latin typeface="Calibri"/>
               </a:rPr>
-              <a:t>Adaptive Guided Work Instructions</a:t>
+              <a:t>Adaptive Guided</a:t>
+            </a:r>
+          </a:p>
+          <a:p>
+            <a:pPr algn="l"/>
+            <a:r>
+              <a:rPr sz="1350" b="1">
+                <a:solidFill>
+                  <a:srgbClr val="FFFFFF"/>
+                </a:solidFill>
+                <a:latin typeface="Calibri"/>
+              </a:rPr>
+              <a:t>Work Instructions</a:t>
             </a:r>
           </a:p>
         </p:txBody>
@@ -9364,8 +9379,8 @@
         </p:nvSpPr>
         <p:spPr>
           <a:xfrm>
-            <a:off x="579105" y="1325880"/>
-            <a:ext cx="2514537" cy="152400"/>
+            <a:off x="579105" y="1493520"/>
+            <a:ext cx="2514537" cy="137160"/>
           </a:xfrm>
           <a:prstGeom prst="rect">
             <a:avLst/>
@@ -9386,7 +9401,7 @@
                 </a:solidFill>
                 <a:latin typeface="Calibri"/>
               </a:rPr>
-              <a:t>AR OMS  ·  AR OJT (on-the-job training)</a:t>
+              <a:t>Connected Worker AR OMS  ·  AR OJT</a:t>
             </a:r>
           </a:p>
         </p:txBody>
@@ -9399,27 +9414,23 @@
         </p:nvSpPr>
         <p:spPr>
           <a:xfrm>
-            <a:off x="579105" y="1493520"/>
-            <a:ext cx="2514537" cy="762000"/>
-          </a:xfrm>
-          <a:prstGeom prst="rect">
-            <a:avLst/>
-          </a:prstGeom>
-          <a:noFill/>
-        </p:spPr>
-        <p:txBody>
-          <a:bodyPr wrap="square" anchor="t" lIns="36576" rIns="36576" tIns="18288" bIns="18288">
-            <a:spAutoFit/>
-          </a:bodyPr>
-          <a:lstStyle/>
-          <a:p>
-            <a:pPr algn="l">
-              <a:spcAft>
-                <a:spcPts val="200"/>
-              </a:spcAft>
-            </a:pPr>
-            <a:r>
-              <a:rPr sz="950" b="0">
+            <a:off x="579105" y="1630680"/>
+            <a:ext cx="2514537" cy="609600"/>
+          </a:xfrm>
+          <a:prstGeom prst="rect">
+            <a:avLst/>
+          </a:prstGeom>
+          <a:noFill/>
+        </p:spPr>
+        <p:txBody>
+          <a:bodyPr wrap="square" anchor="t" lIns="36576" rIns="36576" tIns="18288" bIns="18288">
+            <a:spAutoFit/>
+          </a:bodyPr>
+          <a:lstStyle/>
+          <a:p>
+            <a:pPr algn="l"/>
+            <a:r>
+              <a:rPr sz="850" b="0">
                 <a:solidFill>
                   <a:srgbClr val="CBD5E1"/>
                 </a:solidFill>
@@ -9429,13 +9440,9 @@
             </a:r>
           </a:p>
           <a:p>
-            <a:pPr algn="l">
-              <a:spcAft>
-                <a:spcPts val="200"/>
-              </a:spcAft>
-            </a:pPr>
-            <a:r>
-              <a:rPr sz="950" b="0">
+            <a:pPr algn="l"/>
+            <a:r>
+              <a:rPr sz="850" b="0">
                 <a:solidFill>
                   <a:srgbClr val="CBD5E1"/>
                 </a:solidFill>
@@ -9445,13 +9452,9 @@
             </a:r>
           </a:p>
           <a:p>
-            <a:pPr algn="l">
-              <a:spcAft>
-                <a:spcPts val="200"/>
-              </a:spcAft>
-            </a:pPr>
-            <a:r>
-              <a:rPr sz="950" b="0">
+            <a:pPr algn="l"/>
+            <a:r>
+              <a:rPr sz="850" b="0">
                 <a:solidFill>
                   <a:srgbClr val="CBD5E1"/>
                 </a:solidFill>
@@ -9461,13 +9464,9 @@
             </a:r>
           </a:p>
           <a:p>
-            <a:pPr algn="l">
-              <a:spcAft>
-                <a:spcPts val="200"/>
-              </a:spcAft>
-            </a:pPr>
-            <a:r>
-              <a:rPr sz="950" b="0">
+            <a:pPr algn="l"/>
+            <a:r>
+              <a:rPr sz="850" b="0">
                 <a:solidFill>
                   <a:srgbClr val="CBD5E1"/>
                 </a:solidFill>
@@ -9568,7 +9567,7 @@
         <p:spPr>
           <a:xfrm>
             <a:off x="3444153" y="1325880"/>
-            <a:ext cx="2514537" cy="152400"/>
+            <a:ext cx="2514537" cy="137160"/>
           </a:xfrm>
           <a:prstGeom prst="rect">
             <a:avLst/>
@@ -9603,7 +9602,7 @@
         <p:spPr>
           <a:xfrm>
             <a:off x="3444153" y="1493520"/>
-            <a:ext cx="2514537" cy="762000"/>
+            <a:ext cx="2514537" cy="609600"/>
           </a:xfrm>
           <a:prstGeom prst="rect">
             <a:avLst/>
@@ -9771,7 +9770,7 @@
         <p:spPr>
           <a:xfrm>
             <a:off x="6309202" y="1493520"/>
-            <a:ext cx="2514537" cy="762000"/>
+            <a:ext cx="2514537" cy="609600"/>
           </a:xfrm>
           <a:prstGeom prst="rect">
             <a:avLst/>
@@ -9939,7 +9938,7 @@
         <p:spPr>
           <a:xfrm>
             <a:off x="9174250" y="1493520"/>
-            <a:ext cx="2514537" cy="762000"/>
+            <a:ext cx="2514537" cy="609600"/>
           </a:xfrm>
           <a:prstGeom prst="rect">
             <a:avLst/>

</xml_diff>